<commit_message>
Inclui bloco de educação e migração no modelo preliminar
Frequência escolar 15-17 (Censo), abandono e distorção idade-série no
ensino médio (INEP 2022) e migração recente (Censo) entram como bloco D,
antes do estado. Foram as candidatas significativas e estáveis entre as
26 testadas. Slides, notas, briefings e exportações regenerados a partir
do código.

Co-Authored-By: Claude Opus 5.5 <noreply@anthropic.com>
</commit_message>
<xml_diff>
--- a/apresentacao/apresentacao_parcial.pptx
+++ b/apresentacao/apresentacao_parcial.pptx
@@ -651,7 +651,7 @@
           <a:p>
             <a:r>
               <a:rPr/>
-              <a:t>[Luiz Felipe] Box-Cox no modelo múltiplo: lambda 0,17 (IC 95% de 0,14 a 0,21). A apostila recomenda um valor de fácil interpretação: adotamos o logaritmo (lambda = 0). A normalidade dos resíduos melhora (W de 0,92 para 0,98).</a:t>
+              <a:t>[Luiz Felipe] Box-Cox no modelo múltiplo: lambda 0,18 (IC 95% de 0,14 a 0,22). A apostila recomenda um valor de fácil interpretação: adotamos o logaritmo (lambda = 0). A normalidade dos resíduos melhora (W de 0,92 para 0,98).</a:t>
             </a:r>
           </a:p>
         </p:txBody>
@@ -698,7 +698,7 @@
           <a:p>
             <a:r>
               <a:rPr/>
-              <a:t>[Luiz Felipe] Entramos com as variáveis em blocos e testamos cada um pelo F parcial (somas de quadrados extras). Usar o estado no lugar da região melhora o modelo (R² ajustado de 0,49 para 0,58; F parcial do estado além da região 17,2) e resolve a correlação entre vizinhos (Durbin-Watson de 1,68 para 2,01). Renda, % pobres e alfabetização juntas: VIF da renda 26, com sinais contraditórios; ficamos só com a renda, centralizada antes do quadrado.</a:t>
+              <a:t>[Luiz Felipe] Entramos com as variáveis em blocos e testamos cada um pelo F parcial (somas de quadrados extras). O bloco de educação e migração entra com F parcial 46,9 (R² ajustado de 0,39 para 0,44). Usar o estado no lugar da região melhora o modelo (R² ajustado de 0,51 para 0,59; F parcial do estado além da região 15,9) e resolve a correlação entre vizinhos (Durbin-Watson de 1,71 para 2,01). Renda, % pobres e alfabetização juntas: VIF da renda 27, com sinais contraditórios; ficamos só com a renda, centralizada antes do quadrado.</a:t>
             </a:r>
           </a:p>
         </p:txBody>
@@ -745,7 +745,7 @@
           <a:p>
             <a:r>
               <a:rPr/>
-              <a:t>[Willian] F global 66 com 36 e 1.673 gl; R² ajustado 0,58. Como a resposta é ln(taxa), cada efeito é a variação percentual da taxa para a mudança indicada, com as outras variáveis constantes. Em cinza, as não significativas. % intenção indeterminada mede subnotificação, não risco; desocupação vem da amostra do Censo e deve ser lida com cautela.</a:t>
+              <a:t>[Willian] F global 62 com 40 e 1.669 gl; R² ajustado 0,59. Como a resposta é ln(taxa), cada efeito é a variação percentual da taxa para a mudança indicada, com as outras variáveis constantes. As não significativas ficam à direita, em cinza. Mais jovens de 15 a 17 na escola, menos homicídios; mais abandono, atraso escolar e migração recente, mais homicídios. % intenção indeterminada mede subnotificação, não risco; desocupação vem da amostra do Censo e deve ser lida com cautela.</a:t>
             </a:r>
           </a:p>
         </p:txBody>
@@ -792,7 +792,7 @@
           <a:p>
             <a:r>
               <a:rPr/>
-              <a:t>[Willian] Curva prevista pelo modelo, com as outras variáveis na média: a taxa esperada é máxima com renda per capita de cerca de R$ 1.039. O pico é diferente do gráfico da exploratória porque aqui as outras variáveis estão controladas. A faixa é o intervalo de confiança de 95% da resposta esperada.</a:t>
+              <a:t>[Willian] Curva prevista pelo modelo, com as outras variáveis na média: a taxa esperada é máxima com renda per capita de cerca de R$ 1.065. O pico é diferente do gráfico da exploratória porque aqui as outras variáveis estão controladas. A faixa é o intervalo de confiança de 95% da resposta esperada.</a:t>
             </a:r>
           </a:p>
         </p:txBody>
@@ -839,7 +839,7 @@
           <a:p>
             <a:r>
               <a:rPr/>
-              <a:t>[Willian] Análise dos resíduos como na apostila. Durbin-Watson = 2,01 (p = 0,70): com o estado no modelo, resíduos de municípios vizinhos deixam de se parecer. Breusch-Pagan = 112: a variância não é constante, então os valores p são aproximados. Normalidade razoável (W = 0,98). 2 outliers, mantidos porque não são erro de dado.</a:t>
+              <a:t>[Willian] Análise dos resíduos como na apostila. Durbin-Watson = 2,01 (p = 0,66): com o estado no modelo, resíduos de municípios vizinhos deixam de se parecer. Breusch-Pagan = 110: a variância não é constante, então os valores p são aproximados. Normalidade razoável (W = 0,98). 1 outliers, mantidos porque não são erro de dado.</a:t>
             </a:r>
           </a:p>
         </p:txBody>
@@ -1215,7 +1215,7 @@
           <a:p>
             <a:r>
               <a:rPr/>
-              <a:t>[Fabio] Resposta: SIM/DATASUS, registro oficial de óbitos do Ministério da Saúde: óbitos por agressão (CID-10 X85–Y09) e intervenção legal (Y35–Y36), por município de residência, somados de 2021 a 2023 e divididos por 3 vezes a população. Explicativas: Censo 2022, pela API do SIDRA. As bases se ligam pelo código IBGE do município.</a:t>
+              <a:t>[Fabio] Resposta: SIM/DATASUS, registro oficial de óbitos do Ministério da Saúde: óbitos por agressão (CID-10 X85–Y09) e intervenção legal (Y35–Y36), por município de residência, somados de 2021 a 2023 e divididos por 3 vezes a população. Explicativas: Censo 2022, pela API do SIDRA (inclui frequência escolar e migração), e INEP 2022 (Censo Escolar: abandono e distorção idade-série no ensino médio). As bases se ligam pelo código IBGE do município.</a:t>
             </a:r>
           </a:p>
         </p:txBody>
@@ -1262,7 +1262,7 @@
           <a:p>
             <a:r>
               <a:rPr/>
-              <a:t>[Fabio] A resposta é quantitativa contínua. Amazônia Legal: região definida em lei (9 estados). Faixa de fronteira: 150 km ao longo da fronteira terrestre. Estado entra como 26 indicadoras, com SP como referência.</a:t>
+              <a:t>[Fabio] A resposta é quantitativa contínua. Distorção idade-série: % de alunos do ensino médio com 2 anos ou mais de atraso. Migração recente: % de moradores há menos de 10 anos no município. Amazônia Legal: região definida em lei (9 estados). Faixa de fronteira: 150 km ao longo da fronteira terrestre. Estado entra como 26 indicadoras, com SP como referência.</a:t>
             </a:r>
           </a:p>
         </p:txBody>

</xml_diff>

<commit_message>
Simplifica a exploratória e tira o slide do escopo
- Histograma só da taxa, sem o log, para mostrar a assimetria à direita
- Boxplot só por região, sem Amazônia Legal e faixa de fronteira
- Matriz de correlação sem os tópicos ao lado
- Slide do escopo removido; o escopo de 20 mil hab. passa para o item
  de contagens pequenas nas limitações
- Notas, briefings e exportação .pptx/.html atualizados

Co-Authored-By: Claude Opus 5.5 <noreply@anthropic.com>
</commit_message>
<xml_diff>
--- a/apresentacao/apresentacao_parcial.pptx
+++ b/apresentacao/apresentacao_parcial.pptx
@@ -33,7 +33,6 @@
     <p:sldId id="278" r:id="rId31"/>
     <p:sldId id="279" r:id="rId32"/>
     <p:sldId id="280" r:id="rId33"/>
-    <p:sldId id="281" r:id="rId34"/>
   </p:sldIdLst>
   <p:sldSz cx="12192000" cy="6858000"/>
   <p:notesSz cx="6858000" cy="9144000"/>
@@ -564,7 +563,7 @@
           <a:p>
             <a:r>
               <a:rPr/>
-              <a:t>[Fabio] A oscilação é o erro relativo esperado só pelo acaso, um sobre a raiz do número esperado de homicídios. Abaixo de 5 mil habitantes a mediana é 1 homicídio em 3 anos e a taxa oscila ±66%; a taxa de 2024 quase não repete a de 2021–23 (correlação 0,26, contra 0,89 nos maiores). Por isso toda a análise usa os municípios com 20 mil habitantes ou mais (apostila, cap. 1: escopo do modelo): 1.710 municípios, 84% da população, nenhum com taxa zero.</a:t>
+              <a:t>[Douglas] Daqui em diante, só os 1.710 municípios do escopo. A tabela resume a resposta e as explicativas do modelo, com escalas e dispersões bem diferentes. A densidade é muito assimétrica, com média muito acima da mediana, por isso entra em logaritmo no modelo.</a:t>
             </a:r>
           </a:p>
         </p:txBody>
@@ -611,7 +610,7 @@
           <a:p>
             <a:r>
               <a:rPr/>
-              <a:t>[Douglas] Daqui em diante, só os 1.710 municípios do escopo. A tabela resume a resposta e as explicativas do modelo, com escalas e dispersões bem diferentes. A densidade é muito assimétrica, com média muito acima da mediana, por isso entra em logaritmo no modelo.</a:t>
+              <a:t>[Douglas] O histograma mostra a assimetria da taxa: metade dos municípios fica entre 11,1 e 35,0 homicídios por 100 mil, mas há uma cauda longa à direita, com poucos municípios muito violentos. Por isso a média (25,0) fica acima da mediana (20,5), e o coeficiente de assimetria é 1,36, positivo. Essa assimetria sugere transformar a resposta antes do modelo; o Box-Cox, adiante, indica qual transformação usar.</a:t>
             </a:r>
           </a:p>
         </p:txBody>
@@ -658,7 +657,7 @@
           <a:p>
             <a:r>
               <a:rPr/>
-              <a:t>[Douglas] O histograma confirma a assimetria da taxa: cauda longa à direita (coeficiente de assimetria 1,36). No log a distribuição fica quase simétrica (−0,49). Isso já sugere transformar a resposta, o que o Box-Cox confirma adiante.</a:t>
+              <a:t>[Douglas] O mapa e os boxplots mostram a mesma coisa por dois ângulos: Norte e Nordeste ficam acima de Sudeste e Sul. Como a taxa muda tanto de um lugar para outro, o estado entra no modelo como variável categórica. Por isso a Amazônia Legal fica de fora: com o estado no modelo, ela fica redundante.</a:t>
             </a:r>
           </a:p>
         </p:txBody>
@@ -705,7 +704,7 @@
           <a:p>
             <a:r>
               <a:rPr/>
-              <a:t>[Douglas] O mapa e os boxplots mostram a mesma coisa por dois ângulos: Norte e Nordeste ficam acima de Sudeste e Sul. Na Amazônia Legal a mediana é 30,1, contra 18,0 no resto; na faixa de fronteira, 18,4 contra 20,7. Como a taxa muda tanto de um lugar para outro, o estado entra no modelo como variável categórica. A Amazônia Legal sai: com o estado no modelo, ela fica redundante.</a:t>
+              <a:t>[Douglas] Correlação de Pearson de cada explicativa com o log da taxa. A maior é a de % preta/parda (0,56). Nenhuma variável sozinha basta: precisamos de um modelo múltiplo.</a:t>
             </a:r>
           </a:p>
         </p:txBody>
@@ -752,7 +751,7 @@
           <a:p>
             <a:r>
               <a:rPr/>
-              <a:t>[Douglas] Correlação de Pearson de cada explicativa com o log da taxa. A maior é a de % preta/parda (0,56). Nenhuma variável sozinha basta: precisamos de um modelo múltiplo.</a:t>
+              <a:t>[Douglas] A matriz mostra a dispersão e a correlação entre pares de variáveis. Renda, % pobres e alfabetização têm correlação entre si de até 0,92: medem quase a mesma coisa. Com as três no modelo, o VIF da renda chega a 27. Por isso fica só a renda.</a:t>
             </a:r>
           </a:p>
         </p:txBody>
@@ -799,7 +798,7 @@
           <a:p>
             <a:r>
               <a:rPr/>
-              <a:t>[Douglas] A matriz mostra a dispersão e a correlação entre pares de variáveis. Renda, % pobres e alfabetização têm correlação entre si de até 0,92: medem quase a mesma coisa. Com as três no modelo, o VIF da renda chega a 27. Por isso fica só a renda.</a:t>
+              <a:t>[Luiz Felipe] Cada caixa é um décimo dos municípios por renda. Nos dados, a taxa é maior nos décimos de renda média (pico perto de R$ 803) e cai nos dois extremos: isso pede um termo de renda ao quadrado (modelo polinomial de 2a ordem).</a:t>
             </a:r>
           </a:p>
         </p:txBody>
@@ -846,7 +845,7 @@
           <a:p>
             <a:r>
               <a:rPr/>
-              <a:t>[Luiz Felipe] Cada caixa é um décimo dos municípios por renda. Nos dados, a taxa é maior nos décimos de renda média (pico perto de R$ 803) e cai nos dois extremos: isso pede um termo de renda ao quadrado (modelo polinomial de 2a ordem).</a:t>
+              <a:t>[Luiz Felipe] Box-Cox no modelo múltiplo: lambda estimado 0,18, com IC 95% de 0,14 a 0,22. O zero fica fora do intervalo; mesmo assim adotamos o logaritmo (lambda = 0), porque a apostila recomenda um valor de fácil interpretação próximo do estimado e o log permite ler os efeitos em %. A normalidade dos resíduos melhora (W de 0,92 para 0,98).</a:t>
             </a:r>
           </a:p>
         </p:txBody>
@@ -893,7 +892,7 @@
           <a:p>
             <a:r>
               <a:rPr/>
-              <a:t>[Luiz Felipe] Box-Cox no modelo múltiplo: lambda estimado 0,18, com IC 95% de 0,14 a 0,22. O zero fica fora do intervalo; mesmo assim adotamos o logaritmo (lambda = 0), porque a apostila recomenda um valor de fácil interpretação próximo do estimado e o log permite ler os efeitos em %. A normalidade dos resíduos melhora (W de 0,92 para 0,98).</a:t>
+              <a:t>[Luiz Felipe] Esta é a equação do modelo. A resposta é o log da taxa. A renda entra centralizada na média e ao quadrado; centralizar reduz a correlação entre renda e renda ao quadrado de 0,9995 para −0,11. O vetor x reúne as outras 12 explicativas dos blocos A a D, e as D são as 26 indicadoras de estado, com SP de referência. Estimamos por mínimos quadrados ordinários, com 1.710 municípios e 41 parâmetros, supondo erros independentes, normais e de variância constante; o diagnóstico verifica essas hipóteses.</a:t>
             </a:r>
           </a:p>
         </p:txBody>
@@ -940,7 +939,7 @@
           <a:p>
             <a:r>
               <a:rPr/>
-              <a:t>[Luiz Felipe] Esta é a equação do modelo. A resposta é o log da taxa. A renda entra centralizada na média e ao quadrado; centralizar reduz a correlação entre renda e renda ao quadrado de 0,9995 para −0,11. O vetor x reúne as outras 12 explicativas dos blocos A a D, e as D são as 26 indicadoras de estado, com SP de referência. Estimamos por mínimos quadrados ordinários, com 1.710 municípios e 41 parâmetros, supondo erros independentes, normais e de variância constante; o diagnóstico verifica essas hipóteses.</a:t>
+              <a:t>[Luiz Felipe] Entramos com as variáveis em blocos e testamos cada um pelo F parcial (somas de quadrados extras); a hipótese nula é que os coeficientes do bloco são todos zero, e ela é rejeitada em todos. O bloco de educação e migração entra com F parcial 46,9 (R² ajustado de 0,39 para 0,44). Usar o estado no lugar da região melhora o modelo: F parcial do estado além da região 15,9 com 22 gl, e R² ajustado de 0,51 para 0,59. O maior ganho de R² ajustado vem do estado, o que confirma a diferença entre lugares vista na exploratória.</a:t>
             </a:r>
           </a:p>
         </p:txBody>
@@ -987,7 +986,7 @@
           <a:p>
             <a:r>
               <a:rPr/>
-              <a:t>[Luiz Felipe] Entramos com as variáveis em blocos e testamos cada um pelo F parcial (somas de quadrados extras); a hipótese nula é que os coeficientes do bloco são todos zero, e ela é rejeitada em todos. O bloco de educação e migração entra com F parcial 46,9 (R² ajustado de 0,39 para 0,44). Usar o estado no lugar da região melhora o modelo: F parcial do estado além da região 15,9 com 22 gl, e R² ajustado de 0,51 para 0,59. O maior ganho de R² ajustado vem do estado, o que confirma a diferença entre lugares vista na exploratória.</a:t>
+              <a:t>[Willian] F global 62 com 40 e 1.669 gl; R² 0,60 e R² ajustado 0,59. Como a resposta é ln(taxa), cada efeito é a variação percentual da taxa para a mudança indicada, 100 vezes exp(b vezes delta) menos 1, com as outras variáveis constantes; ao lado, o intervalo de confiança de 95%. A primeira coluna liga cada variável à hipótese: desigualdade (H1), as três de escola (H2) e migração recente (H3) têm o sinal esperado. % intenção indeterminada mede subnotificação, não risco; desocupação vem da amostra do Censo e deve ser lida com cautela.</a:t>
             </a:r>
           </a:p>
         </p:txBody>
@@ -1081,7 +1080,7 @@
           <a:p>
             <a:r>
               <a:rPr/>
-              <a:t>[Willian] F global 62 com 40 e 1.669 gl; R² 0,60 e R² ajustado 0,59. Como a resposta é ln(taxa), cada efeito é a variação percentual da taxa para a mudança indicada, 100 vezes exp(b vezes delta) menos 1, com as outras variáveis constantes; ao lado, o intervalo de confiança de 95%. A primeira coluna liga cada variável à hipótese: desigualdade (H1), as três de escola (H2) e migração recente (H3) têm o sinal esperado. % intenção indeterminada mede subnotificação, não risco; desocupação vem da amostra do Censo e deve ser lida com cautela.</a:t>
+              <a:t>[Willian] Curva prevista pelo modelo, com as outras variáveis na média e o estado de referência: o coeficiente da renda ao quadrado é −0,548, negativo, então a curva é côncava. O máximo fica onde a derivada zera, menos beta 1 sobre 2 beta 2, o que dá renda per capita de cerca de R$ 1.065. O pico é diferente do gráfico da exploratória porque aqui as outras variáveis estão controladas. A faixa é o intervalo de confiança de 95% da resposta esperada.</a:t>
             </a:r>
           </a:p>
         </p:txBody>
@@ -1128,7 +1127,7 @@
           <a:p>
             <a:r>
               <a:rPr/>
-              <a:t>[Willian] Curva prevista pelo modelo, com as outras variáveis na média e o estado de referência: o coeficiente da renda ao quadrado é −0,548, negativo, então a curva é côncava. O máximo fica onde a derivada zera, menos beta 1 sobre 2 beta 2, o que dá renda per capita de cerca de R$ 1.065. O pico é diferente do gráfico da exploratória porque aqui as outras variáveis estão controladas. A faixa é o intervalo de confiança de 95% da resposta esperada.</a:t>
+              <a:t>[Willian] Análise dos resíduos como na apostila. Normalidade: Shapiro-Wilk W = 0,98; com mais de mil observações o teste rejeita mesmo com W perto de 1. No gráfico de quantis o centro segue a reta, mas a cauda esquerda é mais pesada: alguns municípios têm taxa bem abaixo da prevista. Variância: Breusch-Pagan = 110 com 40 gl, rejeita; os erros-padrão e valores p são aproximados. Durbin-Watson = 2,01 (p = 0,66), calculado na ordem do código IBGE, que dentro de cada estado é quase alfabética: ele não avalia a dependência entre vizinhos geográficos, que fica para a próxima etapa. VIF máximo 12,7, o da renda. 1 outlier (Nhamundá-AM), mantido porque não é erro de dado.</a:t>
             </a:r>
           </a:p>
         </p:txBody>
@@ -1175,7 +1174,7 @@
           <a:p>
             <a:r>
               <a:rPr/>
-              <a:t>[Willian] Análise dos resíduos como na apostila. Normalidade: Shapiro-Wilk W = 0,98; com mais de mil observações o teste rejeita mesmo com W perto de 1. No gráfico de quantis o centro segue a reta, mas a cauda esquerda é mais pesada: alguns municípios têm taxa bem abaixo da prevista. Variância: Breusch-Pagan = 110 com 40 gl, rejeita; os erros-padrão e valores p são aproximados. Durbin-Watson = 2,01 (p = 0,66), calculado na ordem do código IBGE, que dentro de cada estado é quase alfabética: ele não avalia a dependência entre vizinhos geográficos, que fica para a próxima etapa. VIF máximo 12,7, o da renda. 1 outlier (Nhamundá-AM), mantido porque não é erro de dado.</a:t>
+              <a:t>[Willian] Voltando à pergunta: no resultado preliminar, há mais homicídios onde há mais desigualdade, mais exclusão escolar e mais migração recente, como nas três hipóteses; a renda tem efeito em U invertido, e os estados diferem muito entre si. Isso está de acordo com a literatura: urbanização e desigualdade têm o mesmo sinal de Wanzinack et al., e a diferença entre estados aparece também em Castellucci e Silva. Próximos passos: seleção de variáveis pelo cap. 8 da apostila (Cp, AIC, BIC, PRESS); tratar a variância não constante; e verificar se os resíduos de municípios vizinhos se parecem, a dependência espacial que Barros et al. encontraram.</a:t>
             </a:r>
           </a:p>
         </p:txBody>
@@ -1222,7 +1221,7 @@
           <a:p>
             <a:r>
               <a:rPr/>
-              <a:t>[Willian] Voltando à pergunta: no resultado preliminar, há mais homicídios onde há mais desigualdade, mais exclusão escolar e mais migração recente, como nas três hipóteses; a renda tem efeito em U invertido, e os estados diferem muito entre si. Isso está de acordo com a literatura: urbanização e desigualdade têm o mesmo sinal de Wanzinack et al., e a diferença entre estados aparece também em Castellucci e Silva. Próximos passos: seleção de variáveis pelo cap. 8 da apostila (Cp, AIC, BIC, PRESS); tratar a variância não constante; e verificar se os resíduos de municípios vizinhos se parecem, a dependência espacial que Barros et al. encontraram.</a:t>
+              <a:t>[Willian] Agradecer e abrir para perguntas.</a:t>
             </a:r>
           </a:p>
         </p:txBody>
@@ -1269,7 +1268,7 @@
           <a:p>
             <a:r>
               <a:rPr/>
-              <a:t>[Willian] Agradecer e abrir para perguntas.</a:t>
+              <a:t>Tabela para perguntas. Coeficientes na escala de ln(taxa), com erro-padrão: 100 × b é a variação percentual aproximada da taxa.</a:t>
             </a:r>
           </a:p>
         </p:txBody>
@@ -1316,53 +1315,6 @@
           <a:p>
             <a:r>
               <a:rPr/>
-              <a:t>Tabela para perguntas. Coeficientes na escala de ln(taxa), com erro-padrão: 100 × b é a variação percentual aproximada da taxa.</a:t>
-            </a:r>
-          </a:p>
-        </p:txBody>
-      </p:sp>
-    </p:spTree>
-  </p:cSld>
-  <p:clrMapOvr>
-    <a:masterClrMapping/>
-  </p:clrMapOvr>
-</p:notes>
-</file>
-
-<file path=ppt/notesSlides/notesSlide26.xml><?xml version="1.0" encoding="utf-8"?>
-<p:notes xmlns:a="http://schemas.openxmlformats.org/drawingml/2006/main" xmlns:r="http://schemas.openxmlformats.org/officeDocument/2006/relationships" xmlns:p="http://schemas.openxmlformats.org/presentationml/2006/main">
-  <p:cSld>
-    <p:spTree>
-      <p:nvGrpSpPr>
-        <p:cNvPr id="1" name=""/>
-        <p:cNvGrpSpPr/>
-        <p:nvPr/>
-      </p:nvGrpSpPr>
-      <p:grpSpPr>
-        <a:xfrm>
-          <a:off x="0" y="0"/>
-          <a:ext cx="0" cy="0"/>
-          <a:chOff x="0" y="0"/>
-          <a:chExt cx="0" cy="0"/>
-        </a:xfrm>
-      </p:grpSpPr>
-      <p:sp>
-        <p:nvSpPr>
-          <p:cNvPr id="2" name="Notes Placeholder 4"/>
-          <p:cNvSpPr>
-            <a:spLocks noGrp="1"/>
-          </p:cNvSpPr>
-          <p:nvPr>
-            <p:ph type="body" sz="quarter" idx="3"/>
-          </p:nvPr>
-        </p:nvSpPr>
-        <p:spPr/>
-        <p:txBody>
-          <a:bodyPr/>
-          <a:lstStyle/>
-          <a:p>
-            <a:r>
-              <a:rPr/>
               <a:t>Referências completas das hipóteses, do método e das fontes de dados.</a:t>
             </a:r>
           </a:p>
@@ -1692,7 +1644,7 @@
           <a:p>
             <a:r>
               <a:rPr/>
-              <a:t>[Fabio] É um estudo observacional e ecológico: mostra associação entre municípios, não causa, e não vale para indivíduos (falácia ecológica). Usamos homicídios registrados: onde muitas mortes ficam como 'intenção indeterminada', parte dos homicídios fica escondida. O Censo conta os presos como moradores do município do presídio. E, nos municípios pequenos, o homicídio é raro: poucos casos e muitos zeros (655 municípios sem nenhum homicídio) fazem a taxa oscilar por acaso.</a:t>
+              <a:t>[Fabio] É um estudo observacional e ecológico: mostra associação entre municípios, não causa, e não vale para indivíduos (falácia ecológica). Usamos homicídios registrados: onde muitas mortes ficam como 'intenção indeterminada', parte dos homicídios fica escondida. O Censo conta os presos como moradores do município do presídio. E, nos municípios pequenos, o homicídio é raro: poucos casos e muitos zeros (655 municípios sem nenhum homicídio) fazem a taxa oscilar por acaso. Por isso toda a análise usa os municípios com 20 mil habitantes ou mais (apostila, cap. 1: escopo do modelo): 1.710 municípios, 84% da população, nenhum com taxa zero.</a:t>
             </a:r>
           </a:p>
         </p:txBody>
@@ -4660,57 +4612,6 @@
 </file>
 
 <file path=ppt/slides/slide25.xml><?xml version="1.0" encoding="utf-8"?>
-<p:sld xmlns:a="http://schemas.openxmlformats.org/drawingml/2006/main" xmlns:r="http://schemas.openxmlformats.org/officeDocument/2006/relationships" xmlns:p="http://schemas.openxmlformats.org/presentationml/2006/main">
-  <p:cSld>
-    <p:spTree>
-      <p:nvGrpSpPr>
-        <p:cNvPr id="1" name=""/>
-        <p:cNvGrpSpPr/>
-        <p:nvPr/>
-      </p:nvGrpSpPr>
-      <p:grpSpPr>
-        <a:xfrm>
-          <a:off x="0" y="0"/>
-          <a:ext cx="0" cy="0"/>
-          <a:chOff x="0" y="0"/>
-          <a:chExt cx="0" cy="0"/>
-        </a:xfrm>
-      </p:grpSpPr>
-      <p:pic>
-        <p:nvPicPr>
-          <p:cNvPr id="2" name="" descr=""/>
-          <p:cNvPicPr>
-            <a:picLocks noGrp="1"/>
-          </p:cNvPicPr>
-          <p:nvPr>
-            <p:ph/>
-          </p:nvPr>
-        </p:nvPicPr>
-        <p:blipFill>
-          <a:blip r:embed="rId3"/>
-          <a:stretch>
-            <a:fillRect/>
-          </a:stretch>
-        </p:blipFill>
-        <p:spPr>
-          <a:xfrm>
-            <a:off x="0" y="0"/>
-            <a:ext cx="12191695" cy="6858000"/>
-          </a:xfrm>
-          <a:prstGeom prst="rect">
-            <a:avLst/>
-          </a:prstGeom>
-        </p:spPr>
-      </p:pic>
-    </p:spTree>
-  </p:cSld>
-  <p:clrMapOvr>
-    <a:masterClrMapping/>
-  </p:clrMapOvr>
-</p:sld>
-</file>
-
-<file path=ppt/slides/slide26.xml><?xml version="1.0" encoding="utf-8"?>
 <p:sld xmlns:a="http://schemas.openxmlformats.org/drawingml/2006/main" xmlns:r="http://schemas.openxmlformats.org/officeDocument/2006/relationships" xmlns:p="http://schemas.openxmlformats.org/presentationml/2006/main">
   <p:cSld>
     <p:spTree>

</xml_diff>